<commit_message>
downscaled final panel powerpoint
</commit_message>
<xml_diff>
--- a/Academic Documents/Final Panel Presentation/BHB - Final Panel Presentation.pptx
+++ b/Academic Documents/Final Panel Presentation/BHB - Final Panel Presentation.pptx
@@ -3321,7 +3321,7 @@
           </a:prstGeom>
           <a:extLst>
             <a:ext uri="{C572A759-6A51-4108-AA02-DFA0A04FC94B}">
-              <ma14:wrappingTextBoxFlag xmlns="" xmlns:ma14="http://schemas.microsoft.com/office/mac/drawingml/2011/main" val="0"/>
+              <ma14:wrappingTextBoxFlag xmlns:ma14="http://schemas.microsoft.com/office/mac/drawingml/2011/main" xmlns="" val="0"/>
             </a:ext>
           </a:extLst>
         </p:spPr>
@@ -3751,7 +3751,7 @@
           </a:prstGeom>
           <a:extLst>
             <a:ext uri="{C572A759-6A51-4108-AA02-DFA0A04FC94B}">
-              <ma14:wrappingTextBoxFlag xmlns="" xmlns:ma14="http://schemas.microsoft.com/office/mac/drawingml/2011/main" val="0"/>
+              <ma14:wrappingTextBoxFlag xmlns:ma14="http://schemas.microsoft.com/office/mac/drawingml/2011/main" xmlns="" val="0"/>
             </a:ext>
           </a:extLst>
         </p:spPr>
@@ -4049,7 +4049,7 @@
           </a:prstGeom>
           <a:extLst>
             <a:ext uri="{C572A759-6A51-4108-AA02-DFA0A04FC94B}">
-              <ma14:wrappingTextBoxFlag xmlns="" xmlns:ma14="http://schemas.microsoft.com/office/mac/drawingml/2011/main" val="0"/>
+              <ma14:wrappingTextBoxFlag xmlns:ma14="http://schemas.microsoft.com/office/mac/drawingml/2011/main" xmlns="" val="0"/>
             </a:ext>
           </a:extLst>
         </p:spPr>
@@ -4796,7 +4796,7 @@
           </a:prstGeom>
           <a:extLst>
             <a:ext uri="{C572A759-6A51-4108-AA02-DFA0A04FC94B}">
-              <ma14:wrappingTextBoxFlag xmlns="" xmlns:ma14="http://schemas.microsoft.com/office/mac/drawingml/2011/main" val="0"/>
+              <ma14:wrappingTextBoxFlag xmlns:ma14="http://schemas.microsoft.com/office/mac/drawingml/2011/main" xmlns="" val="0"/>
             </a:ext>
           </a:extLst>
         </p:spPr>
@@ -6799,7 +6799,7 @@
           </a:prstGeom>
           <a:extLst>
             <a:ext uri="{C572A759-6A51-4108-AA02-DFA0A04FC94B}">
-              <ma14:wrappingTextBoxFlag xmlns="" xmlns:ma14="http://schemas.microsoft.com/office/mac/drawingml/2011/main" val="0"/>
+              <ma14:wrappingTextBoxFlag xmlns:ma14="http://schemas.microsoft.com/office/mac/drawingml/2011/main" xmlns="" val="0"/>
             </a:ext>
           </a:extLst>
         </p:spPr>
@@ -8786,7 +8786,7 @@
           </a:prstGeom>
           <a:extLst>
             <a:ext uri="{C572A759-6A51-4108-AA02-DFA0A04FC94B}">
-              <ma14:wrappingTextBoxFlag xmlns="" xmlns:ma14="http://schemas.microsoft.com/office/mac/drawingml/2011/main" val="0"/>
+              <ma14:wrappingTextBoxFlag xmlns:ma14="http://schemas.microsoft.com/office/mac/drawingml/2011/main" xmlns="" val="0"/>
             </a:ext>
           </a:extLst>
         </p:spPr>
@@ -10010,7 +10010,7 @@
           </a:prstGeom>
           <a:extLst>
             <a:ext uri="{C572A759-6A51-4108-AA02-DFA0A04FC94B}">
-              <ma14:wrappingTextBoxFlag xmlns="" xmlns:ma14="http://schemas.microsoft.com/office/mac/drawingml/2011/main" val="0"/>
+              <ma14:wrappingTextBoxFlag xmlns:ma14="http://schemas.microsoft.com/office/mac/drawingml/2011/main" xmlns="" val="0"/>
             </a:ext>
           </a:extLst>
         </p:spPr>
@@ -11174,7 +11174,7 @@
           </a:prstGeom>
           <a:extLst>
             <a:ext uri="{C572A759-6A51-4108-AA02-DFA0A04FC94B}">
-              <ma14:wrappingTextBoxFlag xmlns="" xmlns:ma14="http://schemas.microsoft.com/office/mac/drawingml/2011/main" val="0"/>
+              <ma14:wrappingTextBoxFlag xmlns:ma14="http://schemas.microsoft.com/office/mac/drawingml/2011/main" xmlns="" val="0"/>
             </a:ext>
           </a:extLst>
         </p:spPr>
@@ -12283,7 +12283,7 @@
           </a:prstGeom>
           <a:extLst>
             <a:ext uri="{C572A759-6A51-4108-AA02-DFA0A04FC94B}">
-              <ma14:wrappingTextBoxFlag xmlns="" xmlns:ma14="http://schemas.microsoft.com/office/mac/drawingml/2011/main" val="0"/>
+              <ma14:wrappingTextBoxFlag xmlns:ma14="http://schemas.microsoft.com/office/mac/drawingml/2011/main" xmlns="" val="0"/>
             </a:ext>
           </a:extLst>
         </p:spPr>
@@ -13122,7 +13122,7 @@
           </a:prstGeom>
           <a:extLst>
             <a:ext uri="{C572A759-6A51-4108-AA02-DFA0A04FC94B}">
-              <ma14:wrappingTextBoxFlag xmlns="" xmlns:ma14="http://schemas.microsoft.com/office/mac/drawingml/2011/main" val="0"/>
+              <ma14:wrappingTextBoxFlag xmlns:ma14="http://schemas.microsoft.com/office/mac/drawingml/2011/main" xmlns="" val="0"/>
             </a:ext>
           </a:extLst>
         </p:spPr>
@@ -13484,7 +13484,7 @@
           </a:prstGeom>
           <a:extLst>
             <a:ext uri="{C572A759-6A51-4108-AA02-DFA0A04FC94B}">
-              <ma14:wrappingTextBoxFlag xmlns="" xmlns:ma14="http://schemas.microsoft.com/office/mac/drawingml/2011/main" val="0"/>
+              <ma14:wrappingTextBoxFlag xmlns:ma14="http://schemas.microsoft.com/office/mac/drawingml/2011/main" xmlns="" val="0"/>
             </a:ext>
           </a:extLst>
         </p:spPr>
@@ -15368,7 +15368,7 @@
           </a:prstGeom>
           <a:extLst>
             <a:ext uri="{C572A759-6A51-4108-AA02-DFA0A04FC94B}">
-              <ma14:wrappingTextBoxFlag xmlns="" xmlns:ma14="http://schemas.microsoft.com/office/mac/drawingml/2011/main" val="0"/>
+              <ma14:wrappingTextBoxFlag xmlns:ma14="http://schemas.microsoft.com/office/mac/drawingml/2011/main" xmlns="" val="0"/>
             </a:ext>
           </a:extLst>
         </p:spPr>
@@ -17634,15 +17634,7 @@
           <a:p>
             <a:r>
               <a:rPr lang="en-US" dirty="0"/>
-              <a:t>Primary </a:t>
-            </a:r>
-            <a:r>
-              <a:rPr lang="en-US"/>
-              <a:t>Artefact</a:t>
-            </a:r>
-            <a:r>
-              <a:rPr lang="en-US" dirty="0"/>
-              <a:t> (1/2)</a:t>
+              <a:t>Primary Artefact (1/2)</a:t>
             </a:r>
             <a:endParaRPr lang="en-NZ" dirty="0"/>
           </a:p>
@@ -17721,7 +17713,13 @@
           <p:nvPr/>
         </p:nvPicPr>
         <p:blipFill>
-          <a:blip r:embed="rId2"/>
+          <a:blip r:embed="rId2">
+            <a:extLst>
+              <a:ext uri="{28A0092B-C50C-407E-A947-70E740481C1C}">
+                <a14:useLocalDpi xmlns:a14="http://schemas.microsoft.com/office/drawing/2010/main" val="0"/>
+              </a:ext>
+            </a:extLst>
+          </a:blip>
           <a:stretch>
             <a:fillRect/>
           </a:stretch>
@@ -17751,7 +17749,13 @@
           <p:nvPr/>
         </p:nvPicPr>
         <p:blipFill>
-          <a:blip r:embed="rId3"/>
+          <a:blip r:embed="rId3">
+            <a:extLst>
+              <a:ext uri="{28A0092B-C50C-407E-A947-70E740481C1C}">
+                <a14:useLocalDpi xmlns:a14="http://schemas.microsoft.com/office/drawing/2010/main" val="0"/>
+              </a:ext>
+            </a:extLst>
+          </a:blip>
           <a:stretch>
             <a:fillRect/>
           </a:stretch>
@@ -17781,7 +17785,13 @@
           <p:nvPr/>
         </p:nvPicPr>
         <p:blipFill>
-          <a:blip r:embed="rId4"/>
+          <a:blip r:embed="rId4">
+            <a:extLst>
+              <a:ext uri="{28A0092B-C50C-407E-A947-70E740481C1C}">
+                <a14:useLocalDpi xmlns:a14="http://schemas.microsoft.com/office/drawing/2010/main" val="0"/>
+              </a:ext>
+            </a:extLst>
+          </a:blip>
           <a:stretch>
             <a:fillRect/>
           </a:stretch>
@@ -18010,7 +18020,13 @@
           </p:nvPr>
         </p:nvPicPr>
         <p:blipFill>
-          <a:blip r:embed="rId2"/>
+          <a:blip r:embed="rId2" cstate="email">
+            <a:extLst>
+              <a:ext uri="{28A0092B-C50C-407E-A947-70E740481C1C}">
+                <a14:useLocalDpi xmlns:a14="http://schemas.microsoft.com/office/drawing/2010/main"/>
+              </a:ext>
+            </a:extLst>
+          </a:blip>
           <a:stretch>
             <a:fillRect/>
           </a:stretch>
@@ -18198,10 +18214,10 @@
       </p:sp>
       <p:pic>
         <p:nvPicPr>
-          <p:cNvPr id="8" name="Picture 7">
+          <p:cNvPr id="4" name="Picture 3">
             <a:extLst>
               <a:ext uri="{FF2B5EF4-FFF2-40B4-BE49-F238E27FC236}">
-                <a16:creationId xmlns:a16="http://schemas.microsoft.com/office/drawing/2014/main" id="{A8490EDA-6FF1-5B60-86B9-2345D59497E2}"/>
+                <a16:creationId xmlns:a16="http://schemas.microsoft.com/office/drawing/2014/main" id="{862121A5-BA28-C005-9A0B-42B656CD4A40}"/>
               </a:ext>
             </a:extLst>
           </p:cNvPr>
@@ -18211,24 +18227,30 @@
           <p:nvPr/>
         </p:nvPicPr>
         <p:blipFill>
-          <a:blip r:embed="rId2"/>
+          <a:blip r:embed="rId2" cstate="email">
+            <a:extLst>
+              <a:ext uri="{28A0092B-C50C-407E-A947-70E740481C1C}">
+                <a14:useLocalDpi xmlns:a14="http://schemas.microsoft.com/office/drawing/2010/main"/>
+              </a:ext>
+            </a:extLst>
+          </a:blip>
           <a:stretch>
             <a:fillRect/>
           </a:stretch>
         </p:blipFill>
         <p:spPr>
           <a:xfrm>
-            <a:off x="7391103" y="527671"/>
-            <a:ext cx="4470697" cy="5802657"/>
+            <a:off x="7195913" y="542925"/>
+            <a:ext cx="4508534" cy="5772150"/>
           </a:xfrm>
           <a:prstGeom prst="rect">
             <a:avLst/>
           </a:prstGeom>
           <a:ln w="38100">
             <a:solidFill>
-              <a:schemeClr val="accent1">
-                <a:lumMod val="60000"/>
-                <a:lumOff val="40000"/>
+              <a:schemeClr val="tx2">
+                <a:lumMod val="50000"/>
+                <a:lumOff val="50000"/>
               </a:schemeClr>
             </a:solidFill>
           </a:ln>
@@ -18376,10 +18398,10 @@
       </p:sp>
       <p:pic>
         <p:nvPicPr>
-          <p:cNvPr id="13" name="Picture 12">
+          <p:cNvPr id="6" name="Picture 5">
             <a:extLst>
               <a:ext uri="{FF2B5EF4-FFF2-40B4-BE49-F238E27FC236}">
-                <a16:creationId xmlns:a16="http://schemas.microsoft.com/office/drawing/2014/main" id="{4E431470-A6E7-2402-C4AC-F4500A7EDA92}"/>
+                <a16:creationId xmlns:a16="http://schemas.microsoft.com/office/drawing/2014/main" id="{5D8B900F-6352-F3AB-7150-BFA93DC35475}"/>
               </a:ext>
             </a:extLst>
           </p:cNvPr>
@@ -18389,15 +18411,21 @@
           <p:nvPr/>
         </p:nvPicPr>
         <p:blipFill>
-          <a:blip r:embed="rId3"/>
+          <a:blip r:embed="rId3">
+            <a:extLst>
+              <a:ext uri="{28A0092B-C50C-407E-A947-70E740481C1C}">
+                <a14:useLocalDpi xmlns:a14="http://schemas.microsoft.com/office/drawing/2010/main" val="0"/>
+              </a:ext>
+            </a:extLst>
+          </a:blip>
           <a:stretch>
             <a:fillRect/>
           </a:stretch>
         </p:blipFill>
         <p:spPr>
           <a:xfrm>
-            <a:off x="548640" y="2230958"/>
-            <a:ext cx="2597591" cy="3675442"/>
+            <a:off x="3938520" y="1944604"/>
+            <a:ext cx="2767281" cy="4248150"/>
           </a:xfrm>
           <a:prstGeom prst="rect">
             <a:avLst/>
@@ -18406,10 +18434,10 @@
       </p:pic>
       <p:pic>
         <p:nvPicPr>
-          <p:cNvPr id="17" name="Picture 16">
+          <p:cNvPr id="8" name="Picture 7">
             <a:extLst>
               <a:ext uri="{FF2B5EF4-FFF2-40B4-BE49-F238E27FC236}">
-                <a16:creationId xmlns:a16="http://schemas.microsoft.com/office/drawing/2014/main" id="{28CA2B34-38CB-6433-D901-05EAEC190943}"/>
+                <a16:creationId xmlns:a16="http://schemas.microsoft.com/office/drawing/2014/main" id="{2AE6B567-10C8-335C-BDB8-35475894173F}"/>
               </a:ext>
             </a:extLst>
           </p:cNvPr>
@@ -18419,15 +18447,21 @@
           <p:nvPr/>
         </p:nvPicPr>
         <p:blipFill>
-          <a:blip r:embed="rId4"/>
+          <a:blip r:embed="rId4">
+            <a:extLst>
+              <a:ext uri="{28A0092B-C50C-407E-A947-70E740481C1C}">
+                <a14:useLocalDpi xmlns:a14="http://schemas.microsoft.com/office/drawing/2010/main" val="0"/>
+              </a:ext>
+            </a:extLst>
+          </a:blip>
           <a:stretch>
             <a:fillRect/>
           </a:stretch>
         </p:blipFill>
         <p:spPr>
           <a:xfrm>
-            <a:off x="3807951" y="2202445"/>
-            <a:ext cx="2707149" cy="4087718"/>
+            <a:off x="666603" y="1764291"/>
+            <a:ext cx="3177188" cy="4248150"/>
           </a:xfrm>
           <a:prstGeom prst="rect">
             <a:avLst/>
@@ -18686,7 +18720,13 @@
           <p:nvPr/>
         </p:nvPicPr>
         <p:blipFill>
-          <a:blip r:embed="rId2"/>
+          <a:blip r:embed="rId2">
+            <a:extLst>
+              <a:ext uri="{28A0092B-C50C-407E-A947-70E740481C1C}">
+                <a14:useLocalDpi xmlns:a14="http://schemas.microsoft.com/office/drawing/2010/main" val="0"/>
+              </a:ext>
+            </a:extLst>
+          </a:blip>
           <a:stretch>
             <a:fillRect/>
           </a:stretch>
@@ -19000,10 +19040,10 @@
                     <a:lstStyle/>
                     <a:p>
                       <a:r>
-                        <a:rPr lang="en-US"/>
+                        <a:rPr lang="en-US" dirty="0"/>
                         <a:t>Limitations</a:t>
                       </a:r>
-                      <a:endParaRPr lang="en-NZ"/>
+                      <a:endParaRPr lang="en-NZ" dirty="0"/>
                     </a:p>
                   </a:txBody>
                   <a:tcPr/>
@@ -19141,10 +19181,10 @@
       </p:sp>
       <p:pic>
         <p:nvPicPr>
-          <p:cNvPr id="9" name="Picture 8">
+          <p:cNvPr id="7" name="Picture 6">
             <a:extLst>
               <a:ext uri="{FF2B5EF4-FFF2-40B4-BE49-F238E27FC236}">
-                <a16:creationId xmlns:a16="http://schemas.microsoft.com/office/drawing/2014/main" id="{7249B54C-37C4-5AB3-836F-32A220EE6BBF}"/>
+                <a16:creationId xmlns:a16="http://schemas.microsoft.com/office/drawing/2014/main" id="{01BD5367-41C0-B504-4546-CE50C4387709}"/>
               </a:ext>
             </a:extLst>
           </p:cNvPr>
@@ -19154,22 +19194,25 @@
           <p:nvPr/>
         </p:nvPicPr>
         <p:blipFill>
-          <a:blip r:embed="rId2"/>
+          <a:blip r:embed="rId2" cstate="screen">
+            <a:extLst>
+              <a:ext uri="{28A0092B-C50C-407E-A947-70E740481C1C}">
+                <a14:useLocalDpi xmlns:a14="http://schemas.microsoft.com/office/drawing/2010/main"/>
+              </a:ext>
+            </a:extLst>
+          </a:blip>
           <a:stretch>
             <a:fillRect/>
           </a:stretch>
         </p:blipFill>
         <p:spPr>
           <a:xfrm>
-            <a:off x="7208797" y="165100"/>
-            <a:ext cx="3917494" cy="6189980"/>
+            <a:off x="7436767" y="320667"/>
+            <a:ext cx="3742946" cy="5761034"/>
           </a:xfrm>
           <a:prstGeom prst="rect">
             <a:avLst/>
           </a:prstGeom>
-          <a:effectLst>
-            <a:softEdge rad="38100"/>
-          </a:effectLst>
         </p:spPr>
       </p:pic>
     </p:spTree>
@@ -19444,7 +19487,6 @@
               <a:rPr lang="en-NZ" dirty="0"/>
               <a:t>Number of reports and time it takes for </a:t>
             </a:r>
-            <a:endParaRPr lang="en-NZ"/>
           </a:p>
         </p:txBody>
       </p:sp>
@@ -19701,10 +19743,10 @@
       </p:sp>
       <p:pic>
         <p:nvPicPr>
-          <p:cNvPr id="17" name="Picture 16">
+          <p:cNvPr id="7" name="Picture 6">
             <a:extLst>
               <a:ext uri="{FF2B5EF4-FFF2-40B4-BE49-F238E27FC236}">
-                <a16:creationId xmlns:a16="http://schemas.microsoft.com/office/drawing/2014/main" id="{40EC537A-0738-9E7E-C940-6E15E145D1BA}"/>
+                <a16:creationId xmlns:a16="http://schemas.microsoft.com/office/drawing/2014/main" id="{C72988D8-A822-0020-7C17-FE97DF4C9A54}"/>
               </a:ext>
             </a:extLst>
           </p:cNvPr>
@@ -19714,28 +19756,25 @@
           <p:nvPr/>
         </p:nvPicPr>
         <p:blipFill>
-          <a:blip r:embed="rId3"/>
-          <a:srcRect l="2627" r="817"/>
+          <a:blip r:embed="rId3">
+            <a:extLst>
+              <a:ext uri="{28A0092B-C50C-407E-A947-70E740481C1C}">
+                <a14:useLocalDpi xmlns:a14="http://schemas.microsoft.com/office/drawing/2010/main"/>
+              </a:ext>
+            </a:extLst>
+          </a:blip>
           <a:stretch>
             <a:fillRect/>
           </a:stretch>
         </p:blipFill>
         <p:spPr>
           <a:xfrm>
-            <a:off x="5569752" y="1525726"/>
-            <a:ext cx="6455993" cy="4254376"/>
+            <a:off x="5539588" y="1564934"/>
+            <a:ext cx="6592220" cy="4401164"/>
           </a:xfrm>
           <a:prstGeom prst="rect">
             <a:avLst/>
           </a:prstGeom>
-          <a:ln w="38100">
-            <a:solidFill>
-              <a:schemeClr val="accent2"/>
-            </a:solidFill>
-          </a:ln>
-          <a:effectLst>
-            <a:softEdge rad="0"/>
-          </a:effectLst>
         </p:spPr>
       </p:pic>
     </p:spTree>
@@ -20602,90 +20641,53 @@
           <a:p>
             <a:r>
               <a:rPr lang="en-US" dirty="0"/>
-              <a:t>When </a:t>
-            </a:r>
-            <a:r>
-              <a:rPr lang="en-US"/>
-              <a:t>our client was </a:t>
+              <a:t>When our client was asked if they were happy with the project they replied, "</a:t>
+            </a:r>
+            <a:r>
+              <a:rPr lang="en-US" i="1" dirty="0"/>
+              <a:t>Yes very much so, I am very pleased with the work you guys have done.</a:t>
             </a:r>
             <a:r>
               <a:rPr lang="en-US" dirty="0"/>
-              <a:t>asked if </a:t>
-            </a:r>
-            <a:r>
-              <a:rPr lang="en-US"/>
-              <a:t>they were </a:t>
-            </a:r>
+              <a:t>"</a:t>
+            </a:r>
+          </a:p>
+          <a:p>
+            <a:endParaRPr lang="en-US" dirty="0"/>
+          </a:p>
+          <a:p>
             <a:r>
               <a:rPr lang="en-US" dirty="0"/>
-              <a:t>happy with the project </a:t>
-            </a:r>
-            <a:r>
-              <a:rPr lang="en-US"/>
-              <a:t>they</a:t>
-            </a:r>
-            <a:r>
-              <a:rPr lang="en-US" dirty="0"/>
-              <a:t> replied</a:t>
-            </a:r>
-            <a:r>
-              <a:rPr lang="en-US"/>
-              <a:t>,</a:t>
-            </a:r>
-            <a:r>
-              <a:rPr lang="en-US" dirty="0"/>
-              <a:t> "</a:t>
-            </a:r>
-            <a:r>
-              <a:rPr lang="en-US" i="1"/>
-              <a:t>Yes very much so, I am very pleased with the work you guys have done.</a:t>
-            </a:r>
-            <a:r>
-              <a:rPr lang="en-US"/>
+              <a:t>Other indicative quotes during our client presentation:</a:t>
+            </a:r>
+          </a:p>
+          <a:p>
+            <a:pPr marL="971550" lvl="1"/>
+            <a:r>
+              <a:rPr lang="en-US" sz="1800" dirty="0"/>
               <a:t>"</a:t>
             </a:r>
-            <a:endParaRPr lang="en-US" dirty="0"/>
-          </a:p>
-          <a:p>
-            <a:endParaRPr lang="en-US" dirty="0"/>
-          </a:p>
-          <a:p>
-            <a:r>
-              <a:rPr lang="en-US"/>
-              <a:t>Other indicative quotes during our</a:t>
-            </a:r>
-            <a:r>
-              <a:rPr lang="en-US" dirty="0"/>
-              <a:t> client presentation:</a:t>
+            <a:r>
+              <a:rPr lang="en-US" sz="1800" i="1" dirty="0"/>
+              <a:t>You’ve done a fantastic job on this project.</a:t>
+            </a:r>
+            <a:r>
+              <a:rPr lang="en-US" sz="1800" dirty="0"/>
+              <a:t>"</a:t>
             </a:r>
           </a:p>
           <a:p>
             <a:pPr marL="971550" lvl="1"/>
             <a:r>
-              <a:rPr lang="en-US" sz="1800"/>
+              <a:rPr lang="en-US" sz="1800" dirty="0"/>
               <a:t>"</a:t>
             </a:r>
             <a:r>
-              <a:rPr lang="en-US" sz="1800" i="1"/>
-              <a:t>You’ve done a fantastic job on this project.</a:t>
-            </a:r>
-            <a:r>
-              <a:rPr lang="en-US" sz="1800"/>
-              <a:t>"</a:t>
-            </a:r>
-          </a:p>
-          <a:p>
-            <a:pPr marL="971550" lvl="1"/>
-            <a:r>
-              <a:rPr lang="en-US" sz="1800"/>
-              <a:t>"</a:t>
-            </a:r>
-            <a:r>
-              <a:rPr lang="en-US" sz="1800" i="1"/>
+              <a:rPr lang="en-US" sz="1800" i="1" dirty="0"/>
               <a:t>The thing I'm doing with that Neuromancer game has come from your project</a:t>
             </a:r>
             <a:r>
-              <a:rPr lang="en-US" sz="1800"/>
+              <a:rPr lang="en-US" sz="1800" dirty="0"/>
               <a:t>"</a:t>
             </a:r>
           </a:p>
@@ -23581,38 +23583,6 @@
           </a:p>
         </p:txBody>
       </p:sp>
-      <p:pic>
-        <p:nvPicPr>
-          <p:cNvPr id="8" name="Content Placeholder 7">
-            <a:extLst>
-              <a:ext uri="{FF2B5EF4-FFF2-40B4-BE49-F238E27FC236}">
-                <a16:creationId xmlns:a16="http://schemas.microsoft.com/office/drawing/2014/main" id="{206D23E1-3C7C-41D6-F275-4999BAEDDB9F}"/>
-              </a:ext>
-            </a:extLst>
-          </p:cNvPr>
-          <p:cNvPicPr>
-            <a:picLocks noGrp="1" noChangeAspect="1"/>
-          </p:cNvPicPr>
-          <p:nvPr>
-            <p:ph idx="101"/>
-          </p:nvPr>
-        </p:nvPicPr>
-        <p:blipFill>
-          <a:blip r:embed="rId2"/>
-          <a:stretch>
-            <a:fillRect/>
-          </a:stretch>
-        </p:blipFill>
-        <p:spPr>
-          <a:xfrm>
-            <a:off x="548640" y="1686173"/>
-            <a:ext cx="7497763" cy="4217491"/>
-          </a:xfrm>
-          <a:prstGeom prst="rect">
-            <a:avLst/>
-          </a:prstGeom>
-        </p:spPr>
-      </p:pic>
       <p:sp>
         <p:nvSpPr>
           <p:cNvPr id="3" name="Slide Number Placeholder 2">
@@ -23648,6 +23618,46 @@
           </a:p>
         </p:txBody>
       </p:sp>
+      <p:pic>
+        <p:nvPicPr>
+          <p:cNvPr id="9" name="Content Placeholder 8">
+            <a:extLst>
+              <a:ext uri="{FF2B5EF4-FFF2-40B4-BE49-F238E27FC236}">
+                <a16:creationId xmlns:a16="http://schemas.microsoft.com/office/drawing/2014/main" id="{603198CB-5D97-41D7-9FCF-BF67B419E684}"/>
+              </a:ext>
+            </a:extLst>
+          </p:cNvPr>
+          <p:cNvPicPr>
+            <a:picLocks noGrp="1" noChangeAspect="1"/>
+          </p:cNvPicPr>
+          <p:nvPr>
+            <p:ph idx="101"/>
+          </p:nvPr>
+        </p:nvPicPr>
+        <p:blipFill>
+          <a:blip r:embed="rId2" cstate="email">
+            <a:extLst>
+              <a:ext uri="{28A0092B-C50C-407E-A947-70E740481C1C}">
+                <a14:useLocalDpi xmlns:a14="http://schemas.microsoft.com/office/drawing/2010/main"/>
+              </a:ext>
+            </a:extLst>
+          </a:blip>
+          <a:stretch>
+            <a:fillRect/>
+          </a:stretch>
+        </p:blipFill>
+        <p:spPr>
+          <a:xfrm>
+            <a:off x="549275" y="1556548"/>
+            <a:ext cx="7497763" cy="4403590"/>
+          </a:xfrm>
+          <a:prstGeom prst="rect">
+            <a:avLst/>
+          </a:prstGeom>
+          <a:noFill/>
+          <a:ln/>
+        </p:spPr>
+      </p:pic>
     </p:spTree>
     <p:extLst>
       <p:ext uri="{BB962C8B-B14F-4D97-AF65-F5344CB8AC3E}">
@@ -23898,7 +23908,13 @@
           <p:nvPr/>
         </p:nvPicPr>
         <p:blipFill>
-          <a:blip r:embed="rId2"/>
+          <a:blip r:embed="rId2" cstate="email">
+            <a:extLst>
+              <a:ext uri="{28A0092B-C50C-407E-A947-70E740481C1C}">
+                <a14:useLocalDpi xmlns:a14="http://schemas.microsoft.com/office/drawing/2010/main"/>
+              </a:ext>
+            </a:extLst>
+          </a:blip>
           <a:stretch>
             <a:fillRect/>
           </a:stretch>
@@ -24119,7 +24135,13 @@
           </p:nvPr>
         </p:nvPicPr>
         <p:blipFill>
-          <a:blip r:embed="rId2"/>
+          <a:blip r:embed="rId2" cstate="email">
+            <a:extLst>
+              <a:ext uri="{28A0092B-C50C-407E-A947-70E740481C1C}">
+                <a14:useLocalDpi xmlns:a14="http://schemas.microsoft.com/office/drawing/2010/main"/>
+              </a:ext>
+            </a:extLst>
+          </a:blip>
           <a:stretch>
             <a:fillRect/>
           </a:stretch>
@@ -24219,7 +24241,13 @@
           </p:nvPr>
         </p:nvPicPr>
         <p:blipFill>
-          <a:blip r:embed="rId3"/>
+          <a:blip r:embed="rId3" cstate="email">
+            <a:extLst>
+              <a:ext uri="{28A0092B-C50C-407E-A947-70E740481C1C}">
+                <a14:useLocalDpi xmlns:a14="http://schemas.microsoft.com/office/drawing/2010/main"/>
+              </a:ext>
+            </a:extLst>
+          </a:blip>
           <a:stretch>
             <a:fillRect/>
           </a:stretch>
@@ -24247,10 +24275,10 @@
           </p:nvPr>
         </p:nvPicPr>
         <p:blipFill>
-          <a:blip r:embed="rId4">
+          <a:blip r:embed="rId4" cstate="email">
             <a:extLst>
               <a:ext uri="{28A0092B-C50C-407E-A947-70E740481C1C}">
-                <a14:useLocalDpi xmlns:a14="http://schemas.microsoft.com/office/drawing/2010/main" val="0"/>
+                <a14:useLocalDpi xmlns:a14="http://schemas.microsoft.com/office/drawing/2010/main"/>
               </a:ext>
             </a:extLst>
           </a:blip>
@@ -24382,7 +24410,13 @@
           </p:nvPr>
         </p:nvPicPr>
         <p:blipFill>
-          <a:blip r:embed="rId2"/>
+          <a:blip r:embed="rId2" cstate="email">
+            <a:extLst>
+              <a:ext uri="{28A0092B-C50C-407E-A947-70E740481C1C}">
+                <a14:useLocalDpi xmlns:a14="http://schemas.microsoft.com/office/drawing/2010/main"/>
+              </a:ext>
+            </a:extLst>
+          </a:blip>
           <a:stretch>
             <a:fillRect/>
           </a:stretch>
@@ -24468,7 +24502,13 @@
           </p:nvPr>
         </p:nvPicPr>
         <p:blipFill>
-          <a:blip r:embed="rId3"/>
+          <a:blip r:embed="rId3" cstate="email">
+            <a:extLst>
+              <a:ext uri="{28A0092B-C50C-407E-A947-70E740481C1C}">
+                <a14:useLocalDpi xmlns:a14="http://schemas.microsoft.com/office/drawing/2010/main"/>
+              </a:ext>
+            </a:extLst>
+          </a:blip>
           <a:stretch>
             <a:fillRect/>
           </a:stretch>

</xml_diff>